<commit_message>
docs: mark Zetaris slides live with verified SQL evidence
</commit_message>
<xml_diff>
--- a/HubCrew-Open-Agent-2026.pptx
+++ b/HubCrew-Open-Agent-2026.pptx
@@ -4727,7 +4727,7 @@
                 <a:ea typeface="Open Sans ExtraBold" pitchFamily="34" charset="-122"/>
                 <a:cs typeface="Open Sans ExtraBold" pitchFamily="34" charset="-120"/>
               </a:rPr>
-              <a:t>05 ZETARIS</a:t>
+              <a:t>05 ZETARIS · LIVE</a:t>
             </a:r>
             <a:endParaRPr lang="en-US" sz="1200" dirty="0"/>
           </a:p>
@@ -4769,7 +4769,7 @@
                 <a:ea typeface="Montserrat" pitchFamily="34" charset="-122"/>
                 <a:cs typeface="Montserrat" pitchFamily="34" charset="-120"/>
               </a:rPr>
-              <a:t>Governed SQL before priority or alert — path planned; no live claim yet.</a:t>
+              <a:t>LIVE SQL verified (9/9): 5 TPCDS reason rows inform demo handoff priorities.</a:t>
             </a:r>
             <a:endParaRPr lang="en-US" sz="1100" dirty="0"/>
           </a:p>
@@ -6963,7 +6963,7 @@
                 <a:ea typeface="Open Sans ExtraBold" pitchFamily="34" charset="-122"/>
                 <a:cs typeface="Open Sans ExtraBold" pitchFamily="34" charset="-120"/>
               </a:rPr>
-              <a:t>GOVERNED READ SQL</a:t>
+              <a:t>LIVE GOVERNED READ SQL</a:t>
             </a:r>
             <a:endParaRPr lang="en-US" sz="1200" dirty="0"/>
           </a:p>
@@ -7005,7 +7005,7 @@
                 <a:ea typeface="Montserrat" pitchFamily="34" charset="-122"/>
                 <a:cs typeface="Montserrat" pitchFamily="34" charset="-120"/>
               </a:rPr>
-              <a:t>Zetaris is the data plane: read-only Lightning SQL over sample/home-ops facts before priority or alert decisions. Path: getting-started + sponsors/zetaris docs in open-agent-2026.</a:t>
+              <a:t>Zetaris is live on Mac mini at localhost:3000. Sample facts precede the demo priority mapping: reason sk=2 → P0; sk=1/5 → P1; sk=3/4 → P2. Supplied samples; not production telemetry.</a:t>
             </a:r>
             <a:endParaRPr lang="en-US" sz="1100" dirty="0"/>
           </a:p>
@@ -7064,7 +7064,7 @@
                 <a:ea typeface="Open Sans ExtraBold" pitchFamily="34" charset="-122"/>
                 <a:cs typeface="Open Sans ExtraBold" pitchFamily="34" charset="-120"/>
               </a:rPr>
-              <a:t>DATA PLANE</a:t>
+              <a:t>LIVE DATA PLANE</a:t>
             </a:r>
             <a:endParaRPr lang="en-US" sz="1200" dirty="0"/>
           </a:p>
@@ -7322,7 +7322,7 @@
                 <a:ea typeface="Open Sans ExtraBold" pitchFamily="34" charset="-122"/>
                 <a:cs typeface="Open Sans ExtraBold" pitchFamily="34" charset="-120"/>
               </a:rPr>
-              <a:t>HONEST STATUS</a:t>
+              <a:t>VERIFIED LIVE</a:t>
             </a:r>
             <a:endParaRPr lang="en-US" sz="1200" dirty="0"/>
           </a:p>
@@ -7560,7 +7560,7 @@
                 <a:ea typeface="Open Sans ExtraBold" pitchFamily="34" charset="-122"/>
                 <a:cs typeface="Open Sans ExtraBold" pitchFamily="34" charset="-120"/>
               </a:rPr>
-              <a:t>PLANNED READ PATH</a:t>
+              <a:t>LIVE READ PATH</a:t>
             </a:r>
             <a:endParaRPr lang="en-US" sz="1200" dirty="0"/>
           </a:p>
@@ -7602,7 +7602,7 @@
                 <a:ea typeface="Montserrat" pitchFamily="34" charset="-122"/>
                 <a:cs typeface="Montserrat" pitchFamily="34" charset="-120"/>
               </a:rPr>
-              <a:t>Instance setup in progress — planned checks: SELECT 1; SHOW LIGHTNING DATABASES; sample NY_TAXI / TPCDS LIMIT 5. No live query results claimed on this slide. Refs: zetaris.github.io/getting-started · github.com/zetaris/getting-started</a:t>
+              <a:t>./verify.sh 9/9 PASS · SELECT 1 · SELECT * FROM NY_TAXI.taxi_zones LIMIT 5 · SELECT r_reason_sk, r_reason_desc FROM TPCDS_DB.reason ORDER BY r_reason_sk LIMIT 5. Evidence: sponsors/zetaris/LIVE.md + query_home_ops.md §3 (2026-10-26 Beijing).</a:t>
             </a:r>
             <a:endParaRPr lang="en-US" sz="1100" dirty="0"/>
           </a:p>

</xml_diff>